<commit_message>
add zygo 3d data file
</commit_message>
<xml_diff>
--- a/Zygo Software개발.pptx
+++ b/Zygo Software개발.pptx
@@ -74,6 +74,7 @@
     <p:sldId id="321" r:id="rId68"/>
     <p:sldId id="323" r:id="rId69"/>
     <p:sldId id="324" r:id="rId70"/>
+    <p:sldId id="325" r:id="rId71"/>
   </p:sldIdLst>
   <p:sldSz cx="12192000" cy="6858000"/>
   <p:notesSz cx="6797675" cy="9874250"/>
@@ -311,7 +312,7 @@
           <a:p>
             <a:fld id="{5E2EC1FB-DDCB-48DE-AA18-776941098B20}" type="datetimeFigureOut">
               <a:rPr lang="ko-KR" altLang="en-US" smtClean="0"/>
-              <a:t>2026-03-09</a:t>
+              <a:t>2026-03-10</a:t>
             </a:fld>
             <a:endParaRPr lang="ko-KR" altLang="en-US"/>
           </a:p>
@@ -481,7 +482,7 @@
           <a:p>
             <a:fld id="{5E2EC1FB-DDCB-48DE-AA18-776941098B20}" type="datetimeFigureOut">
               <a:rPr lang="ko-KR" altLang="en-US" smtClean="0"/>
-              <a:t>2026-03-09</a:t>
+              <a:t>2026-03-10</a:t>
             </a:fld>
             <a:endParaRPr lang="ko-KR" altLang="en-US"/>
           </a:p>
@@ -661,7 +662,7 @@
           <a:p>
             <a:fld id="{5E2EC1FB-DDCB-48DE-AA18-776941098B20}" type="datetimeFigureOut">
               <a:rPr lang="ko-KR" altLang="en-US" smtClean="0"/>
-              <a:t>2026-03-09</a:t>
+              <a:t>2026-03-10</a:t>
             </a:fld>
             <a:endParaRPr lang="ko-KR" altLang="en-US"/>
           </a:p>
@@ -831,7 +832,7 @@
           <a:p>
             <a:fld id="{5E2EC1FB-DDCB-48DE-AA18-776941098B20}" type="datetimeFigureOut">
               <a:rPr lang="ko-KR" altLang="en-US" smtClean="0"/>
-              <a:t>2026-03-09</a:t>
+              <a:t>2026-03-10</a:t>
             </a:fld>
             <a:endParaRPr lang="ko-KR" altLang="en-US"/>
           </a:p>
@@ -1077,7 +1078,7 @@
           <a:p>
             <a:fld id="{5E2EC1FB-DDCB-48DE-AA18-776941098B20}" type="datetimeFigureOut">
               <a:rPr lang="ko-KR" altLang="en-US" smtClean="0"/>
-              <a:t>2026-03-09</a:t>
+              <a:t>2026-03-10</a:t>
             </a:fld>
             <a:endParaRPr lang="ko-KR" altLang="en-US"/>
           </a:p>
@@ -1309,7 +1310,7 @@
           <a:p>
             <a:fld id="{5E2EC1FB-DDCB-48DE-AA18-776941098B20}" type="datetimeFigureOut">
               <a:rPr lang="ko-KR" altLang="en-US" smtClean="0"/>
-              <a:t>2026-03-09</a:t>
+              <a:t>2026-03-10</a:t>
             </a:fld>
             <a:endParaRPr lang="ko-KR" altLang="en-US"/>
           </a:p>
@@ -1676,7 +1677,7 @@
           <a:p>
             <a:fld id="{5E2EC1FB-DDCB-48DE-AA18-776941098B20}" type="datetimeFigureOut">
               <a:rPr lang="ko-KR" altLang="en-US" smtClean="0"/>
-              <a:t>2026-03-09</a:t>
+              <a:t>2026-03-10</a:t>
             </a:fld>
             <a:endParaRPr lang="ko-KR" altLang="en-US"/>
           </a:p>
@@ -1794,7 +1795,7 @@
           <a:p>
             <a:fld id="{5E2EC1FB-DDCB-48DE-AA18-776941098B20}" type="datetimeFigureOut">
               <a:rPr lang="ko-KR" altLang="en-US" smtClean="0"/>
-              <a:t>2026-03-09</a:t>
+              <a:t>2026-03-10</a:t>
             </a:fld>
             <a:endParaRPr lang="ko-KR" altLang="en-US"/>
           </a:p>
@@ -1889,7 +1890,7 @@
           <a:p>
             <a:fld id="{5E2EC1FB-DDCB-48DE-AA18-776941098B20}" type="datetimeFigureOut">
               <a:rPr lang="ko-KR" altLang="en-US" smtClean="0"/>
-              <a:t>2026-03-09</a:t>
+              <a:t>2026-03-10</a:t>
             </a:fld>
             <a:endParaRPr lang="ko-KR" altLang="en-US"/>
           </a:p>
@@ -2166,7 +2167,7 @@
           <a:p>
             <a:fld id="{5E2EC1FB-DDCB-48DE-AA18-776941098B20}" type="datetimeFigureOut">
               <a:rPr lang="ko-KR" altLang="en-US" smtClean="0"/>
-              <a:t>2026-03-09</a:t>
+              <a:t>2026-03-10</a:t>
             </a:fld>
             <a:endParaRPr lang="ko-KR" altLang="en-US"/>
           </a:p>
@@ -2419,7 +2420,7 @@
           <a:p>
             <a:fld id="{5E2EC1FB-DDCB-48DE-AA18-776941098B20}" type="datetimeFigureOut">
               <a:rPr lang="ko-KR" altLang="en-US" smtClean="0"/>
-              <a:t>2026-03-09</a:t>
+              <a:t>2026-03-10</a:t>
             </a:fld>
             <a:endParaRPr lang="ko-KR" altLang="en-US"/>
           </a:p>
@@ -2632,7 +2633,7 @@
           <a:p>
             <a:fld id="{5E2EC1FB-DDCB-48DE-AA18-776941098B20}" type="datetimeFigureOut">
               <a:rPr lang="ko-KR" altLang="en-US" smtClean="0"/>
-              <a:t>2026-03-09</a:t>
+              <a:t>2026-03-10</a:t>
             </a:fld>
             <a:endParaRPr lang="ko-KR" altLang="en-US"/>
           </a:p>
@@ -25428,6 +25429,748 @@
 </p:sld>
 </file>
 
+<file path=ppt/slides/slide70.xml><?xml version="1.0" encoding="utf-8"?>
+<p:sld xmlns:a="http://schemas.openxmlformats.org/drawingml/2006/main" xmlns:r="http://schemas.openxmlformats.org/officeDocument/2006/relationships" xmlns:p="http://schemas.openxmlformats.org/presentationml/2006/main">
+  <p:cSld>
+    <p:spTree>
+      <p:nvGrpSpPr>
+        <p:cNvPr id="1" name=""/>
+        <p:cNvGrpSpPr/>
+        <p:nvPr/>
+      </p:nvGrpSpPr>
+      <p:grpSpPr>
+        <a:xfrm>
+          <a:off x="0" y="0"/>
+          <a:ext cx="0" cy="0"/>
+          <a:chOff x="0" y="0"/>
+          <a:chExt cx="0" cy="0"/>
+        </a:xfrm>
+      </p:grpSpPr>
+      <p:sp>
+        <p:nvSpPr>
+          <p:cNvPr id="2" name="제목 1"/>
+          <p:cNvSpPr>
+            <a:spLocks noGrp="1"/>
+          </p:cNvSpPr>
+          <p:nvPr>
+            <p:ph type="title"/>
+          </p:nvPr>
+        </p:nvSpPr>
+        <p:spPr/>
+        <p:txBody>
+          <a:bodyPr/>
+          <a:lstStyle/>
+          <a:p>
+            <a:r>
+              <a:rPr lang="en-US" altLang="ko-KR" dirty="0" smtClean="0"/>
+              <a:t>OpenGL Event </a:t>
+            </a:r>
+            <a:r>
+              <a:rPr lang="ko-KR" altLang="en-US" dirty="0" smtClean="0"/>
+              <a:t>처리</a:t>
+            </a:r>
+            <a:endParaRPr lang="ko-KR" altLang="en-US" dirty="0"/>
+          </a:p>
+        </p:txBody>
+      </p:sp>
+      <p:sp>
+        <p:nvSpPr>
+          <p:cNvPr id="3" name="내용 개체 틀 2"/>
+          <p:cNvSpPr>
+            <a:spLocks noGrp="1"/>
+          </p:cNvSpPr>
+          <p:nvPr>
+            <p:ph idx="1"/>
+          </p:nvPr>
+        </p:nvSpPr>
+        <p:spPr/>
+        <p:txBody>
+          <a:bodyPr>
+            <a:normAutofit fontScale="77500" lnSpcReduction="20000"/>
+          </a:bodyPr>
+          <a:lstStyle/>
+          <a:p>
+            <a:r>
+              <a:rPr lang="en-US" altLang="ko-KR" dirty="0" err="1"/>
+              <a:t>m_pView</a:t>
+            </a:r>
+            <a:r>
+              <a:rPr lang="en-US" altLang="ko-KR" dirty="0"/>
+              <a:t> = new </a:t>
+            </a:r>
+            <a:r>
+              <a:rPr lang="en-US" altLang="ko-KR" dirty="0" err="1"/>
+              <a:t>COpenGLViewEx</a:t>
+            </a:r>
+            <a:r>
+              <a:rPr lang="en-US" altLang="ko-KR" dirty="0"/>
+              <a:t>();</a:t>
+            </a:r>
+            <a:endParaRPr lang="en-US" altLang="ko-KR" dirty="0" smtClean="0"/>
+          </a:p>
+          <a:p>
+            <a:pPr lvl="1"/>
+            <a:r>
+              <a:rPr lang="en-US" altLang="ko-KR" dirty="0" smtClean="0"/>
+              <a:t>void </a:t>
+            </a:r>
+            <a:r>
+              <a:rPr lang="en-US" altLang="ko-KR" dirty="0" err="1"/>
+              <a:t>COpenGLView</a:t>
+            </a:r>
+            <a:r>
+              <a:rPr lang="en-US" altLang="ko-KR" dirty="0"/>
+              <a:t>::</a:t>
+            </a:r>
+            <a:r>
+              <a:rPr lang="en-US" altLang="ko-KR" dirty="0" err="1"/>
+              <a:t>GLRenderScene</a:t>
+            </a:r>
+            <a:r>
+              <a:rPr lang="en-US" altLang="ko-KR" dirty="0"/>
+              <a:t>(</a:t>
+            </a:r>
+            <a:r>
+              <a:rPr lang="en-US" altLang="ko-KR" i="1" dirty="0"/>
+              <a:t>UINT</a:t>
+            </a:r>
+            <a:r>
+              <a:rPr lang="en-US" altLang="ko-KR" dirty="0"/>
+              <a:t> </a:t>
+            </a:r>
+            <a:r>
+              <a:rPr lang="en-US" altLang="ko-KR" dirty="0" err="1" smtClean="0"/>
+              <a:t>nAction</a:t>
+            </a:r>
+            <a:r>
+              <a:rPr lang="en-US" altLang="ko-KR" dirty="0" smtClean="0"/>
+              <a:t>=0, </a:t>
+            </a:r>
+            <a:r>
+              <a:rPr lang="en-US" altLang="ko-KR" dirty="0" err="1"/>
+              <a:t>int</a:t>
+            </a:r>
+            <a:r>
+              <a:rPr lang="en-US" altLang="ko-KR" dirty="0"/>
+              <a:t> </a:t>
+            </a:r>
+            <a:r>
+              <a:rPr lang="en-US" altLang="ko-KR" dirty="0" err="1" smtClean="0"/>
+              <a:t>nKey</a:t>
+            </a:r>
+            <a:r>
+              <a:rPr lang="en-US" altLang="ko-KR" dirty="0" smtClean="0"/>
+              <a:t>=0)</a:t>
+            </a:r>
+            <a:endParaRPr lang="en-US" altLang="ko-KR" b="1" dirty="0" smtClean="0"/>
+          </a:p>
+          <a:p>
+            <a:pPr lvl="2"/>
+            <a:r>
+              <a:rPr lang="en-US" altLang="ko-KR" b="1" dirty="0" err="1" smtClean="0"/>
+              <a:t>m_pParentWnd</a:t>
+            </a:r>
+            <a:r>
+              <a:rPr lang="en-US" altLang="ko-KR" b="1" dirty="0" smtClean="0"/>
+              <a:t>-</a:t>
+            </a:r>
+            <a:r>
+              <a:rPr lang="en-US" altLang="ko-KR" b="1" dirty="0"/>
+              <a:t>&gt;</a:t>
+            </a:r>
+            <a:r>
+              <a:rPr lang="en-US" altLang="ko-KR" b="1" i="1" dirty="0" err="1"/>
+              <a:t>SendMessage</a:t>
+            </a:r>
+            <a:r>
+              <a:rPr lang="en-US" altLang="ko-KR" b="1" dirty="0"/>
+              <a:t>(</a:t>
+            </a:r>
+            <a:r>
+              <a:rPr lang="en-US" altLang="ko-KR" b="1" dirty="0">
+                <a:solidFill>
+                  <a:srgbClr val="00B0F0"/>
+                </a:solidFill>
+              </a:rPr>
+              <a:t>WM_USER_RENDER</a:t>
+            </a:r>
+            <a:r>
+              <a:rPr lang="en-US" altLang="ko-KR" b="1" dirty="0"/>
+              <a:t>, </a:t>
+            </a:r>
+            <a:r>
+              <a:rPr lang="en-US" altLang="ko-KR" b="1" dirty="0" err="1"/>
+              <a:t>m_nHandleID</a:t>
+            </a:r>
+            <a:r>
+              <a:rPr lang="en-US" altLang="ko-KR" b="1" dirty="0"/>
+              <a:t>, </a:t>
+            </a:r>
+            <a:r>
+              <a:rPr lang="en-US" altLang="ko-KR" b="1" dirty="0" err="1"/>
+              <a:t>nAction</a:t>
+            </a:r>
+            <a:r>
+              <a:rPr lang="en-US" altLang="ko-KR" b="1" dirty="0" smtClean="0"/>
+              <a:t>);</a:t>
+            </a:r>
+          </a:p>
+          <a:p>
+            <a:pPr lvl="3"/>
+            <a:r>
+              <a:rPr lang="en-US" altLang="ko-KR" b="1" dirty="0" err="1"/>
+              <a:t>m_nHandleID</a:t>
+            </a:r>
+            <a:r>
+              <a:rPr lang="en-US" altLang="ko-KR" b="1" dirty="0"/>
+              <a:t> </a:t>
+            </a:r>
+            <a:r>
+              <a:rPr lang="en-US" altLang="ko-KR" b="1" dirty="0" smtClean="0"/>
+              <a:t>: </a:t>
+            </a:r>
+            <a:r>
+              <a:rPr lang="en-US" altLang="ko-KR" dirty="0" smtClean="0"/>
+              <a:t>IDC_STATIC_VIEW</a:t>
+            </a:r>
+          </a:p>
+          <a:p>
+            <a:pPr lvl="3"/>
+            <a:r>
+              <a:rPr lang="en-US" altLang="ko-KR" b="1" dirty="0" err="1" smtClean="0"/>
+              <a:t>nAction</a:t>
+            </a:r>
+            <a:r>
+              <a:rPr lang="en-US" altLang="ko-KR" b="1" dirty="0" smtClean="0"/>
+              <a:t> : </a:t>
+            </a:r>
+          </a:p>
+          <a:p>
+            <a:pPr lvl="4"/>
+            <a:r>
+              <a:rPr lang="en-US" altLang="ko-KR" dirty="0" smtClean="0"/>
+              <a:t>WM_MOUSEWHEEL, WM_PAINT, WM_FIT_TO_SCREEN, </a:t>
+            </a:r>
+          </a:p>
+          <a:p>
+            <a:pPr lvl="4"/>
+            <a:r>
+              <a:rPr lang="en-US" altLang="ko-KR" dirty="0"/>
+              <a:t>WM_LBUTTONDOWN, </a:t>
+            </a:r>
+            <a:r>
+              <a:rPr lang="en-US" altLang="ko-KR" dirty="0" smtClean="0"/>
+              <a:t>WM_MOUSEMOVE, WM_LBUTTONUP,</a:t>
+            </a:r>
+          </a:p>
+          <a:p>
+            <a:pPr lvl="4"/>
+            <a:r>
+              <a:rPr lang="en-US" altLang="ko-KR" dirty="0" smtClean="0"/>
+              <a:t>WM_MBUTTONDOWN, WM_MBUTTONUP, </a:t>
+            </a:r>
+          </a:p>
+          <a:p>
+            <a:pPr lvl="4"/>
+            <a:r>
+              <a:rPr lang="en-US" altLang="ko-KR" dirty="0" smtClean="0"/>
+              <a:t>WM_RBUTTONDOWN</a:t>
+            </a:r>
+            <a:r>
+              <a:rPr lang="en-US" altLang="ko-KR" dirty="0"/>
+              <a:t>, </a:t>
+            </a:r>
+            <a:r>
+              <a:rPr lang="en-US" altLang="ko-KR" dirty="0" smtClean="0"/>
+              <a:t>WM_RBUTTONUP</a:t>
+            </a:r>
+            <a:endParaRPr lang="en-US" altLang="ko-KR" i="1" dirty="0" smtClean="0"/>
+          </a:p>
+          <a:p>
+            <a:pPr lvl="2"/>
+            <a:r>
+              <a:rPr lang="en-US" altLang="ko-KR" i="1" dirty="0" smtClean="0"/>
+              <a:t>LRESULT</a:t>
+            </a:r>
+            <a:r>
+              <a:rPr lang="en-US" altLang="ko-KR" dirty="0" smtClean="0"/>
+              <a:t> </a:t>
+            </a:r>
+            <a:r>
+              <a:rPr lang="en-US" altLang="ko-KR" dirty="0"/>
+              <a:t>CDlg3DViewer::</a:t>
+            </a:r>
+            <a:r>
+              <a:rPr lang="en-US" altLang="ko-KR" dirty="0" err="1"/>
+              <a:t>OnGLRender</a:t>
+            </a:r>
+            <a:r>
+              <a:rPr lang="en-US" altLang="ko-KR" dirty="0"/>
+              <a:t>(</a:t>
+            </a:r>
+            <a:r>
+              <a:rPr lang="en-US" altLang="ko-KR" i="1" dirty="0"/>
+              <a:t>WPARAM</a:t>
+            </a:r>
+            <a:r>
+              <a:rPr lang="en-US" altLang="ko-KR" dirty="0"/>
+              <a:t> </a:t>
+            </a:r>
+            <a:r>
+              <a:rPr lang="en-US" altLang="ko-KR" dirty="0" err="1"/>
+              <a:t>wParam</a:t>
+            </a:r>
+            <a:r>
+              <a:rPr lang="en-US" altLang="ko-KR" dirty="0"/>
+              <a:t>, </a:t>
+            </a:r>
+            <a:r>
+              <a:rPr lang="en-US" altLang="ko-KR" i="1" dirty="0"/>
+              <a:t>LPARAM</a:t>
+            </a:r>
+            <a:r>
+              <a:rPr lang="en-US" altLang="ko-KR" dirty="0"/>
+              <a:t> </a:t>
+            </a:r>
+            <a:r>
+              <a:rPr lang="en-US" altLang="ko-KR" dirty="0" err="1"/>
+              <a:t>lParam</a:t>
+            </a:r>
+            <a:r>
+              <a:rPr lang="en-US" altLang="ko-KR" dirty="0" smtClean="0"/>
+              <a:t>)</a:t>
+            </a:r>
+          </a:p>
+          <a:p>
+            <a:pPr lvl="3"/>
+            <a:r>
+              <a:rPr lang="en-US" altLang="ko-KR" sz="1400" dirty="0"/>
+              <a:t>if (</a:t>
+            </a:r>
+            <a:r>
+              <a:rPr lang="en-US" altLang="ko-KR" sz="1400" dirty="0" err="1"/>
+              <a:t>lParam</a:t>
+            </a:r>
+            <a:r>
+              <a:rPr lang="en-US" altLang="ko-KR" sz="1400" dirty="0"/>
+              <a:t> == </a:t>
+            </a:r>
+            <a:r>
+              <a:rPr lang="en-US" altLang="ko-KR" sz="1400" i="1" dirty="0"/>
+              <a:t>WM_LBUTTONDOWN</a:t>
+            </a:r>
+            <a:r>
+              <a:rPr lang="en-US" altLang="ko-KR" sz="1400" dirty="0" smtClean="0"/>
+              <a:t>)	</a:t>
+            </a:r>
+            <a:r>
+              <a:rPr lang="en-US" altLang="ko-KR" sz="1400" dirty="0"/>
+              <a:t> _</a:t>
+            </a:r>
+            <a:r>
+              <a:rPr lang="en-US" altLang="ko-KR" sz="1400" dirty="0" err="1"/>
+              <a:t>mouseDownPoint</a:t>
+            </a:r>
+            <a:r>
+              <a:rPr lang="en-US" altLang="ko-KR" sz="1400" dirty="0"/>
+              <a:t> = </a:t>
+            </a:r>
+            <a:r>
+              <a:rPr lang="en-US" altLang="ko-KR" sz="1400" dirty="0" err="1"/>
+              <a:t>m_pView</a:t>
+            </a:r>
+            <a:r>
+              <a:rPr lang="en-US" altLang="ko-KR" sz="1400" dirty="0"/>
+              <a:t>-&gt;</a:t>
+            </a:r>
+            <a:r>
+              <a:rPr lang="en-US" altLang="ko-KR" sz="1400" dirty="0" err="1"/>
+              <a:t>m_ptCurPos</a:t>
+            </a:r>
+            <a:r>
+              <a:rPr lang="en-US" altLang="ko-KR" sz="1400" dirty="0" smtClean="0"/>
+              <a:t>;</a:t>
+            </a:r>
+          </a:p>
+          <a:p>
+            <a:pPr lvl="3"/>
+            <a:r>
+              <a:rPr lang="en-US" altLang="ko-KR" sz="1400" dirty="0"/>
+              <a:t>else if (</a:t>
+            </a:r>
+            <a:r>
+              <a:rPr lang="en-US" altLang="ko-KR" sz="1400" dirty="0" err="1"/>
+              <a:t>lParam</a:t>
+            </a:r>
+            <a:r>
+              <a:rPr lang="en-US" altLang="ko-KR" sz="1400" dirty="0"/>
+              <a:t> == </a:t>
+            </a:r>
+            <a:r>
+              <a:rPr lang="en-US" altLang="ko-KR" sz="1400" i="1" dirty="0"/>
+              <a:t>WM_LBUTTONUP</a:t>
+            </a:r>
+            <a:r>
+              <a:rPr lang="en-US" altLang="ko-KR" sz="1400" dirty="0" smtClean="0"/>
+              <a:t>)</a:t>
+            </a:r>
+            <a:r>
+              <a:rPr lang="en-US" altLang="ko-KR" sz="1400" dirty="0"/>
+              <a:t> </a:t>
+            </a:r>
+            <a:r>
+              <a:rPr lang="en-US" altLang="ko-KR" sz="1400" dirty="0" smtClean="0"/>
+              <a:t>_</a:t>
+            </a:r>
+            <a:r>
+              <a:rPr lang="en-US" altLang="ko-KR" sz="1400" dirty="0" err="1"/>
+              <a:t>mouseDownPoint</a:t>
+            </a:r>
+            <a:r>
+              <a:rPr lang="en-US" altLang="ko-KR" sz="1400" dirty="0"/>
+              <a:t> = </a:t>
+            </a:r>
+            <a:r>
+              <a:rPr lang="en-US" altLang="ko-KR" sz="1400" i="1" dirty="0" err="1"/>
+              <a:t>CPoint</a:t>
+            </a:r>
+            <a:r>
+              <a:rPr lang="en-US" altLang="ko-KR" sz="1400" dirty="0"/>
+              <a:t>(0, 0</a:t>
+            </a:r>
+            <a:r>
+              <a:rPr lang="en-US" altLang="ko-KR" sz="1400" dirty="0" smtClean="0"/>
+              <a:t>);</a:t>
+            </a:r>
+          </a:p>
+          <a:p>
+            <a:pPr lvl="3"/>
+            <a:r>
+              <a:rPr lang="en-US" altLang="ko-KR" sz="1400" dirty="0"/>
+              <a:t>else if (</a:t>
+            </a:r>
+            <a:r>
+              <a:rPr lang="en-US" altLang="ko-KR" sz="1400" dirty="0" err="1"/>
+              <a:t>lParam</a:t>
+            </a:r>
+            <a:r>
+              <a:rPr lang="en-US" altLang="ko-KR" sz="1400" dirty="0"/>
+              <a:t> == </a:t>
+            </a:r>
+            <a:r>
+              <a:rPr lang="en-US" altLang="ko-KR" sz="1400" i="1" dirty="0"/>
+              <a:t>WM_RBUTTONDOWN</a:t>
+            </a:r>
+            <a:r>
+              <a:rPr lang="en-US" altLang="ko-KR" sz="1400" dirty="0" smtClean="0"/>
+              <a:t>) </a:t>
+            </a:r>
+            <a:r>
+              <a:rPr lang="en-US" altLang="ko-KR" sz="1400" dirty="0"/>
+              <a:t>_</a:t>
+            </a:r>
+            <a:r>
+              <a:rPr lang="en-US" altLang="ko-KR" sz="1400" dirty="0" err="1"/>
+              <a:t>mouseDownPoint</a:t>
+            </a:r>
+            <a:r>
+              <a:rPr lang="en-US" altLang="ko-KR" sz="1400" dirty="0"/>
+              <a:t> = </a:t>
+            </a:r>
+            <a:r>
+              <a:rPr lang="en-US" altLang="ko-KR" sz="1400" dirty="0" err="1"/>
+              <a:t>m_pView</a:t>
+            </a:r>
+            <a:r>
+              <a:rPr lang="en-US" altLang="ko-KR" sz="1400" dirty="0"/>
+              <a:t>-&gt;</a:t>
+            </a:r>
+            <a:r>
+              <a:rPr lang="en-US" altLang="ko-KR" sz="1400" dirty="0" err="1"/>
+              <a:t>m_ptCurPos</a:t>
+            </a:r>
+            <a:r>
+              <a:rPr lang="en-US" altLang="ko-KR" sz="1400" dirty="0" smtClean="0"/>
+              <a:t>;</a:t>
+            </a:r>
+          </a:p>
+          <a:p>
+            <a:pPr lvl="3"/>
+            <a:r>
+              <a:rPr lang="en-US" altLang="ko-KR" sz="1400" dirty="0"/>
+              <a:t>else if (</a:t>
+            </a:r>
+            <a:r>
+              <a:rPr lang="en-US" altLang="ko-KR" sz="1400" dirty="0" err="1"/>
+              <a:t>lParam</a:t>
+            </a:r>
+            <a:r>
+              <a:rPr lang="en-US" altLang="ko-KR" sz="1400" dirty="0"/>
+              <a:t> == </a:t>
+            </a:r>
+            <a:r>
+              <a:rPr lang="en-US" altLang="ko-KR" sz="1400" i="1" dirty="0"/>
+              <a:t>WM_RBUTTONUP</a:t>
+            </a:r>
+            <a:r>
+              <a:rPr lang="en-US" altLang="ko-KR" sz="1400" dirty="0" smtClean="0"/>
+              <a:t>) </a:t>
+            </a:r>
+            <a:r>
+              <a:rPr lang="en-US" altLang="ko-KR" sz="1400" dirty="0"/>
+              <a:t>_</a:t>
+            </a:r>
+            <a:r>
+              <a:rPr lang="en-US" altLang="ko-KR" sz="1400" dirty="0" err="1"/>
+              <a:t>mouseDownPoint</a:t>
+            </a:r>
+            <a:r>
+              <a:rPr lang="en-US" altLang="ko-KR" sz="1400" dirty="0"/>
+              <a:t> = </a:t>
+            </a:r>
+            <a:r>
+              <a:rPr lang="en-US" altLang="ko-KR" sz="1400" i="1" dirty="0" err="1"/>
+              <a:t>CPoint</a:t>
+            </a:r>
+            <a:r>
+              <a:rPr lang="en-US" altLang="ko-KR" sz="1400" dirty="0"/>
+              <a:t>(0, 0</a:t>
+            </a:r>
+            <a:r>
+              <a:rPr lang="en-US" altLang="ko-KR" sz="1400" dirty="0" smtClean="0"/>
+              <a:t>);</a:t>
+            </a:r>
+          </a:p>
+          <a:p>
+            <a:pPr lvl="3"/>
+            <a:r>
+              <a:rPr lang="en-US" altLang="ko-KR" sz="1400" dirty="0"/>
+              <a:t>else if (</a:t>
+            </a:r>
+            <a:r>
+              <a:rPr lang="en-US" altLang="ko-KR" sz="1400" dirty="0" err="1"/>
+              <a:t>lParam</a:t>
+            </a:r>
+            <a:r>
+              <a:rPr lang="en-US" altLang="ko-KR" sz="1400" dirty="0"/>
+              <a:t> == </a:t>
+            </a:r>
+            <a:r>
+              <a:rPr lang="en-US" altLang="ko-KR" sz="1400" i="1" dirty="0"/>
+              <a:t>WM_MOUSEHWHEEL</a:t>
+            </a:r>
+            <a:r>
+              <a:rPr lang="en-US" altLang="ko-KR" sz="1400" dirty="0" smtClean="0"/>
+              <a:t>) </a:t>
+            </a:r>
+            <a:r>
+              <a:rPr lang="en-US" altLang="ko-KR" sz="1400" dirty="0" err="1"/>
+              <a:t>m_pView</a:t>
+            </a:r>
+            <a:r>
+              <a:rPr lang="en-US" altLang="ko-KR" sz="1400" dirty="0"/>
+              <a:t>-&gt;</a:t>
+            </a:r>
+            <a:r>
+              <a:rPr lang="en-US" altLang="ko-KR" sz="1400" dirty="0" err="1"/>
+              <a:t>ZoomIn</a:t>
+            </a:r>
+            <a:r>
+              <a:rPr lang="en-US" altLang="ko-KR" sz="1400" dirty="0"/>
+              <a:t>(1.1</a:t>
+            </a:r>
+            <a:r>
+              <a:rPr lang="en-US" altLang="ko-KR" sz="1400" dirty="0" smtClean="0"/>
+              <a:t>); </a:t>
+            </a:r>
+            <a:r>
+              <a:rPr lang="en-US" altLang="ko-KR" sz="1400" dirty="0" err="1"/>
+              <a:t>m_pView</a:t>
+            </a:r>
+            <a:r>
+              <a:rPr lang="en-US" altLang="ko-KR" sz="1400" dirty="0"/>
+              <a:t>-&gt;</a:t>
+            </a:r>
+            <a:r>
+              <a:rPr lang="en-US" altLang="ko-KR" sz="1400" dirty="0" err="1"/>
+              <a:t>ZoomOut</a:t>
+            </a:r>
+            <a:r>
+              <a:rPr lang="en-US" altLang="ko-KR" sz="1400" dirty="0"/>
+              <a:t>(1.1</a:t>
+            </a:r>
+            <a:r>
+              <a:rPr lang="en-US" altLang="ko-KR" sz="1400" dirty="0" smtClean="0"/>
+              <a:t>);</a:t>
+            </a:r>
+          </a:p>
+          <a:p>
+            <a:pPr lvl="3"/>
+            <a:r>
+              <a:rPr lang="en-US" altLang="ko-KR" sz="1400" dirty="0"/>
+              <a:t>else if (</a:t>
+            </a:r>
+            <a:r>
+              <a:rPr lang="en-US" altLang="ko-KR" sz="1400" dirty="0" err="1"/>
+              <a:t>lParam</a:t>
+            </a:r>
+            <a:r>
+              <a:rPr lang="en-US" altLang="ko-KR" sz="1400" dirty="0"/>
+              <a:t> == </a:t>
+            </a:r>
+            <a:r>
+              <a:rPr lang="en-US" altLang="ko-KR" sz="1400" i="1" dirty="0"/>
+              <a:t>WM_MOUSEMOVE</a:t>
+            </a:r>
+            <a:r>
+              <a:rPr lang="en-US" altLang="ko-KR" sz="1400" dirty="0" smtClean="0"/>
+              <a:t>) </a:t>
+            </a:r>
+          </a:p>
+          <a:p>
+            <a:pPr lvl="4"/>
+            <a:r>
+              <a:rPr lang="en-US" altLang="ko-KR" sz="1400" dirty="0"/>
+              <a:t>if (_</a:t>
+            </a:r>
+            <a:r>
+              <a:rPr lang="en-US" altLang="ko-KR" sz="1400" dirty="0" err="1"/>
+              <a:t>mouseButton</a:t>
+            </a:r>
+            <a:r>
+              <a:rPr lang="en-US" altLang="ko-KR" sz="1400" dirty="0"/>
+              <a:t> == 1</a:t>
+            </a:r>
+            <a:r>
+              <a:rPr lang="en-US" altLang="ko-KR" sz="1400" dirty="0" smtClean="0"/>
+              <a:t>) Rotate		// </a:t>
+            </a:r>
+            <a:r>
+              <a:rPr lang="en-US" altLang="ko-KR" sz="1400" dirty="0" err="1"/>
+              <a:t>lParam</a:t>
+            </a:r>
+            <a:r>
+              <a:rPr lang="en-US" altLang="ko-KR" sz="1400" dirty="0"/>
+              <a:t> == </a:t>
+            </a:r>
+            <a:r>
+              <a:rPr lang="en-US" altLang="ko-KR" sz="1400" i="1" dirty="0"/>
+              <a:t>WM_LBUTTONDOWN</a:t>
+            </a:r>
+            <a:endParaRPr lang="en-US" altLang="ko-KR" sz="1400" dirty="0" smtClean="0"/>
+          </a:p>
+          <a:p>
+            <a:pPr lvl="4"/>
+            <a:r>
+              <a:rPr lang="en-US" altLang="ko-KR" sz="1400" dirty="0" smtClean="0"/>
+              <a:t>else </a:t>
+            </a:r>
+            <a:r>
+              <a:rPr lang="en-US" altLang="ko-KR" sz="1400" dirty="0"/>
+              <a:t>if (_</a:t>
+            </a:r>
+            <a:r>
+              <a:rPr lang="en-US" altLang="ko-KR" sz="1400" dirty="0" err="1"/>
+              <a:t>mouseButton</a:t>
+            </a:r>
+            <a:r>
+              <a:rPr lang="en-US" altLang="ko-KR" sz="1400" dirty="0"/>
+              <a:t> == 2</a:t>
+            </a:r>
+            <a:r>
+              <a:rPr lang="en-US" altLang="ko-KR" sz="1400" dirty="0" smtClean="0"/>
+              <a:t>) </a:t>
+            </a:r>
+            <a:r>
+              <a:rPr lang="en-US" altLang="ko-KR" sz="1400" dirty="0" err="1" smtClean="0"/>
+              <a:t>Transiant</a:t>
+            </a:r>
+            <a:r>
+              <a:rPr lang="en-US" altLang="ko-KR" sz="1400" dirty="0" smtClean="0"/>
+              <a:t>	// </a:t>
+            </a:r>
+            <a:r>
+              <a:rPr lang="en-US" altLang="ko-KR" sz="1400" dirty="0" err="1"/>
+              <a:t>lParam</a:t>
+            </a:r>
+            <a:r>
+              <a:rPr lang="en-US" altLang="ko-KR" sz="1400" dirty="0"/>
+              <a:t> == </a:t>
+            </a:r>
+            <a:r>
+              <a:rPr lang="en-US" altLang="ko-KR" sz="1400" i="1" dirty="0"/>
+              <a:t>WM_RBUTTONDOWN</a:t>
+            </a:r>
+            <a:endParaRPr lang="en-US" altLang="ko-KR" sz="1400" dirty="0" smtClean="0"/>
+          </a:p>
+          <a:p>
+            <a:pPr lvl="4"/>
+            <a:r>
+              <a:rPr lang="en-US" altLang="ko-KR" sz="1400" dirty="0"/>
+              <a:t>else if (_</a:t>
+            </a:r>
+            <a:r>
+              <a:rPr lang="en-US" altLang="ko-KR" sz="1400" dirty="0" err="1"/>
+              <a:t>mouseButton</a:t>
+            </a:r>
+            <a:r>
+              <a:rPr lang="en-US" altLang="ko-KR" sz="1400" dirty="0"/>
+              <a:t> == 3</a:t>
+            </a:r>
+            <a:r>
+              <a:rPr lang="en-US" altLang="ko-KR" sz="1400" dirty="0" smtClean="0"/>
+              <a:t>) ?</a:t>
+            </a:r>
+          </a:p>
+          <a:p>
+            <a:pPr lvl="4"/>
+            <a:r>
+              <a:rPr lang="en-US" altLang="ko-KR" sz="1400" dirty="0"/>
+              <a:t>_</a:t>
+            </a:r>
+            <a:r>
+              <a:rPr lang="en-US" altLang="ko-KR" sz="1400" dirty="0" err="1"/>
+              <a:t>mouseDownPoint</a:t>
+            </a:r>
+            <a:r>
+              <a:rPr lang="en-US" altLang="ko-KR" sz="1400" dirty="0"/>
+              <a:t> = </a:t>
+            </a:r>
+            <a:r>
+              <a:rPr lang="en-US" altLang="ko-KR" sz="1400" dirty="0" err="1"/>
+              <a:t>m_pView</a:t>
+            </a:r>
+            <a:r>
+              <a:rPr lang="en-US" altLang="ko-KR" sz="1400" dirty="0"/>
+              <a:t>-&gt;</a:t>
+            </a:r>
+            <a:r>
+              <a:rPr lang="en-US" altLang="ko-KR" sz="1400" dirty="0" err="1"/>
+              <a:t>m_ptCurPos</a:t>
+            </a:r>
+            <a:r>
+              <a:rPr lang="en-US" altLang="ko-KR" sz="1400" dirty="0"/>
+              <a:t>;</a:t>
+            </a:r>
+          </a:p>
+          <a:p>
+            <a:endParaRPr lang="ko-KR" altLang="en-US" dirty="0"/>
+          </a:p>
+        </p:txBody>
+      </p:sp>
+    </p:spTree>
+    <p:extLst>
+      <p:ext uri="{BB962C8B-B14F-4D97-AF65-F5344CB8AC3E}">
+        <p14:creationId xmlns:p14="http://schemas.microsoft.com/office/powerpoint/2010/main" val="2485708467"/>
+      </p:ext>
+    </p:extLst>
+  </p:cSld>
+  <p:clrMapOvr>
+    <a:masterClrMapping/>
+  </p:clrMapOvr>
+</p:sld>
+</file>
+
 <file path=ppt/slides/slide8.xml><?xml version="1.0" encoding="utf-8"?>
 <p:sld xmlns:a="http://schemas.openxmlformats.org/drawingml/2006/main" xmlns:r="http://schemas.openxmlformats.org/officeDocument/2006/relationships" xmlns:p="http://schemas.openxmlformats.org/presentationml/2006/main">
   <p:cSld>

</xml_diff>